<commit_message>
Updating M3 Marking instructions to include successful collection radius and fix inconsistencies
</commit_message>
<xml_diff>
--- a/Week07-08/M3_slides/Lab4_1.pptx
+++ b/Week07-08/M3_slides/Lab4_1.pptx
@@ -206,7 +206,7 @@
           <a:p>
             <a:fld id="{A9407A57-47BC-45C1-B9EB-906F4463B0AB}" type="datetimeFigureOut">
               <a:rPr lang="en-AU" smtClean="0"/>
-              <a:t>6/09/2025</a:t>
+              <a:t>18/09/2025</a:t>
             </a:fld>
             <a:endParaRPr lang="en-AU"/>
           </a:p>
@@ -810,7 +810,7 @@
           <a:p>
             <a:fld id="{1205BC88-DBF0-4610-A802-A09E0A6ECD22}" type="datetimeFigureOut">
               <a:rPr lang="en-AU" smtClean="0"/>
-              <a:t>6/09/2025</a:t>
+              <a:t>18/09/2025</a:t>
             </a:fld>
             <a:endParaRPr lang="en-AU"/>
           </a:p>
@@ -1038,7 +1038,7 @@
           <a:p>
             <a:fld id="{1205BC88-DBF0-4610-A802-A09E0A6ECD22}" type="datetimeFigureOut">
               <a:rPr lang="en-AU" smtClean="0"/>
-              <a:t>6/09/2025</a:t>
+              <a:t>18/09/2025</a:t>
             </a:fld>
             <a:endParaRPr lang="en-AU"/>
           </a:p>
@@ -1218,7 +1218,7 @@
           <a:p>
             <a:fld id="{1205BC88-DBF0-4610-A802-A09E0A6ECD22}" type="datetimeFigureOut">
               <a:rPr lang="en-AU" smtClean="0"/>
-              <a:t>6/09/2025</a:t>
+              <a:t>18/09/2025</a:t>
             </a:fld>
             <a:endParaRPr lang="en-AU"/>
           </a:p>
@@ -1388,7 +1388,7 @@
           <a:p>
             <a:fld id="{1205BC88-DBF0-4610-A802-A09E0A6ECD22}" type="datetimeFigureOut">
               <a:rPr lang="en-AU" smtClean="0"/>
-              <a:t>6/09/2025</a:t>
+              <a:t>18/09/2025</a:t>
             </a:fld>
             <a:endParaRPr lang="en-AU"/>
           </a:p>
@@ -1642,7 +1642,7 @@
           <a:p>
             <a:fld id="{1205BC88-DBF0-4610-A802-A09E0A6ECD22}" type="datetimeFigureOut">
               <a:rPr lang="en-AU" smtClean="0"/>
-              <a:t>6/09/2025</a:t>
+              <a:t>18/09/2025</a:t>
             </a:fld>
             <a:endParaRPr lang="en-AU"/>
           </a:p>
@@ -1968,7 +1968,7 @@
           <a:p>
             <a:fld id="{1205BC88-DBF0-4610-A802-A09E0A6ECD22}" type="datetimeFigureOut">
               <a:rPr lang="en-AU" smtClean="0"/>
-              <a:t>6/09/2025</a:t>
+              <a:t>18/09/2025</a:t>
             </a:fld>
             <a:endParaRPr lang="en-AU"/>
           </a:p>
@@ -2419,7 +2419,7 @@
           <a:p>
             <a:fld id="{1205BC88-DBF0-4610-A802-A09E0A6ECD22}" type="datetimeFigureOut">
               <a:rPr lang="en-AU" smtClean="0"/>
-              <a:t>6/09/2025</a:t>
+              <a:t>18/09/2025</a:t>
             </a:fld>
             <a:endParaRPr lang="en-AU"/>
           </a:p>
@@ -2537,7 +2537,7 @@
           <a:p>
             <a:fld id="{1205BC88-DBF0-4610-A802-A09E0A6ECD22}" type="datetimeFigureOut">
               <a:rPr lang="en-AU" smtClean="0"/>
-              <a:t>6/09/2025</a:t>
+              <a:t>18/09/2025</a:t>
             </a:fld>
             <a:endParaRPr lang="en-AU"/>
           </a:p>
@@ -2632,7 +2632,7 @@
           <a:p>
             <a:fld id="{1205BC88-DBF0-4610-A802-A09E0A6ECD22}" type="datetimeFigureOut">
               <a:rPr lang="en-AU" smtClean="0"/>
-              <a:t>6/09/2025</a:t>
+              <a:t>18/09/2025</a:t>
             </a:fld>
             <a:endParaRPr lang="en-AU"/>
           </a:p>
@@ -2919,7 +2919,7 @@
           <a:p>
             <a:fld id="{1205BC88-DBF0-4610-A802-A09E0A6ECD22}" type="datetimeFigureOut">
               <a:rPr lang="en-AU" smtClean="0"/>
-              <a:t>6/09/2025</a:t>
+              <a:t>18/09/2025</a:t>
             </a:fld>
             <a:endParaRPr lang="en-AU"/>
           </a:p>
@@ -3241,7 +3241,7 @@
           <a:p>
             <a:fld id="{1205BC88-DBF0-4610-A802-A09E0A6ECD22}" type="datetimeFigureOut">
               <a:rPr lang="en-AU" smtClean="0"/>
-              <a:t>6/09/2025</a:t>
+              <a:t>18/09/2025</a:t>
             </a:fld>
             <a:endParaRPr lang="en-AU"/>
           </a:p>
@@ -3495,7 +3495,7 @@
           <a:p>
             <a:fld id="{1205BC88-DBF0-4610-A802-A09E0A6ECD22}" type="datetimeFigureOut">
               <a:rPr lang="en-AU" smtClean="0"/>
-              <a:t>6/09/2025</a:t>
+              <a:t>18/09/2025</a:t>
             </a:fld>
             <a:endParaRPr lang="en-AU"/>
           </a:p>
@@ -7100,7 +7100,7 @@
           <a:p>
             <a:r>
               <a:rPr lang="en-US" dirty="0"/>
-              <a:t>	To “pick up” a target you must stop the robot for 2 seconds (doesn’t need to be exact) whilst being 	within 0.25m of the target. Intention of picking up the fruit needs to be shown in the GUI or terminal.</a:t>
+              <a:t>	To “pick up” a target you must stop the robot for 2 seconds (doesn’t need to be exact) whilst being 	within 0.3m of the target. Intention of picking up the fruit needs to be shown in the GUI or terminal.</a:t>
             </a:r>
           </a:p>
           <a:p>
@@ -8175,7 +8175,7 @@
           <a:p>
             <a:r>
               <a:rPr lang="en-US" dirty="0"/>
-              <a:t>	Max 5 penalties allowed: third time a penalty happens that run is disqualified and gets 0pt </a:t>
+              <a:t>	Max 5 penalties allowed: fifth time a penalty happens that run is disqualified and gets 0pt </a:t>
             </a:r>
           </a:p>
           <a:p>

</xml_diff>